<commit_message>
Fix Slide 5 layout: items overlapping budget badge + recommended badge clipping subtitle
addInvestmentSlide template:
- Item spacing 0.55 -> 0.45, item h 0.5 -> 0.40 (tighter rows)
- Budget badge h 0.72 -> 0.55, position bumped up to free 0.20"
  vertical space for the item list above
- Recommended badge moved from y=sy-0.30 to y=sy-0.15 with h reduced
  from 0.35 to 0.30 so it no longer protrudes into the subtitle line

leyun-intro Slide 5: each tier trimmed from 5 -> 4 items (kept the
strongest 4 per category) so content + budget badge fits cleanly
within the card with margin to spare.

Verified via shape-layout render: items 1-4 end at y=5.55,
budget badge starts at y=5.70 -> 0.15" gap; recommend badge
spans y=1.65-1.95 vs subtitle ending y=1.66 -> no overlap.
</commit_message>
<xml_diff>
--- a/slides/leyun-intro.pptx
+++ b/slides/leyun-intro.pptx
@@ -5839,7 +5839,7 @@
         <p:spPr>
           <a:xfrm>
             <a:off x="640080" y="3474720"/>
-            <a:ext cx="3294888" cy="457200"/>
+            <a:ext cx="3294888" cy="365760"/>
           </a:xfrm>
           <a:prstGeom prst="rect">
             <a:avLst/>
@@ -5877,8 +5877,8 @@
         </p:nvSpPr>
         <p:spPr>
           <a:xfrm>
-            <a:off x="640080" y="3977640"/>
-            <a:ext cx="3294888" cy="457200"/>
+            <a:off x="640080" y="3886200"/>
+            <a:ext cx="3294888" cy="365760"/>
           </a:xfrm>
           <a:prstGeom prst="rect">
             <a:avLst/>
@@ -5916,8 +5916,8 @@
         </p:nvSpPr>
         <p:spPr>
           <a:xfrm>
-            <a:off x="640080" y="4480560"/>
-            <a:ext cx="3294888" cy="457200"/>
+            <a:off x="640080" y="4297680"/>
+            <a:ext cx="3294888" cy="365760"/>
           </a:xfrm>
           <a:prstGeom prst="rect">
             <a:avLst/>
@@ -5941,7 +5941,7 @@
                 <a:ea typeface="微軟正黑體" pitchFamily="34" charset="-122"/>
                 <a:cs typeface="微軟正黑體" pitchFamily="34" charset="-120"/>
               </a:rPr>
-              <a:t>▸  Anycast 自動路由</a:t>
+              <a:t>▸  與 Workers / D1 / KV 原生整合</a:t>
             </a:r>
             <a:endParaRPr lang="en-US" sz="1100" dirty="0"/>
           </a:p>
@@ -5955,8 +5955,8 @@
         </p:nvSpPr>
         <p:spPr>
           <a:xfrm>
-            <a:off x="640080" y="4983480"/>
-            <a:ext cx="3294888" cy="457200"/>
+            <a:off x="640080" y="4709160"/>
+            <a:ext cx="3294888" cy="365760"/>
           </a:xfrm>
           <a:prstGeom prst="rect">
             <a:avLst/>
@@ -5980,7 +5980,7 @@
                 <a:ea typeface="微軟正黑體" pitchFamily="34" charset="-122"/>
                 <a:cs typeface="微軟正黑體" pitchFamily="34" charset="-120"/>
               </a:rPr>
-              <a:t>▸  與 Workers / D1 / KV 原生整合</a:t>
+              <a:t>▸  無 Cold Start 顧慮</a:t>
             </a:r>
             <a:endParaRPr lang="en-US" sz="1100" dirty="0"/>
           </a:p>
@@ -5988,53 +5988,14 @@
       </p:sp>
       <p:sp>
         <p:nvSpPr>
-          <p:cNvPr id="20" name="Text 17"/>
-          <p:cNvSpPr/>
-          <p:nvPr/>
-        </p:nvSpPr>
-        <p:spPr>
-          <a:xfrm>
-            <a:off x="640080" y="5486400"/>
-            <a:ext cx="3294888" cy="457200"/>
-          </a:xfrm>
-          <a:prstGeom prst="rect">
-            <a:avLst/>
-          </a:prstGeom>
-          <a:noFill/>
-          <a:ln/>
-        </p:spPr>
-        <p:txBody>
-          <a:bodyPr wrap="square" rtlCol="0" anchor="ctr"/>
-          <a:lstStyle/>
-          <a:p>
-            <a:pPr indent="0" marL="0">
-              <a:buNone/>
-            </a:pPr>
-            <a:r>
-              <a:rPr lang="en-US" sz="1100" dirty="0">
-                <a:solidFill>
-                  <a:srgbClr val="444444"/>
-                </a:solidFill>
-                <a:latin typeface="微軟正黑體" pitchFamily="34" charset="0"/>
-                <a:ea typeface="微軟正黑體" pitchFamily="34" charset="-122"/>
-                <a:cs typeface="微軟正黑體" pitchFamily="34" charset="-120"/>
-              </a:rPr>
-              <a:t>▸  無 Cold Start 顧慮</a:t>
-            </a:r>
-            <a:endParaRPr lang="en-US" sz="1100" dirty="0"/>
-          </a:p>
-        </p:txBody>
-      </p:sp>
-      <p:sp>
-        <p:nvSpPr>
-          <p:cNvPr id="21" name="Shape 18"/>
-          <p:cNvSpPr/>
-          <p:nvPr/>
-        </p:nvSpPr>
-        <p:spPr>
-          <a:xfrm>
-            <a:off x="640080" y="5029200"/>
-            <a:ext cx="3294888" cy="658368"/>
+          <p:cNvPr id="20" name="Shape 17"/>
+          <p:cNvSpPr/>
+          <p:nvPr/>
+        </p:nvSpPr>
+        <p:spPr>
+          <a:xfrm>
+            <a:off x="640080" y="5212080"/>
+            <a:ext cx="3294888" cy="502920"/>
           </a:xfrm>
           <a:prstGeom prst="rect">
             <a:avLst/>
@@ -6047,14 +6008,14 @@
       </p:sp>
       <p:sp>
         <p:nvSpPr>
-          <p:cNvPr id="22" name="Text 19"/>
-          <p:cNvSpPr/>
-          <p:nvPr/>
-        </p:nvSpPr>
-        <p:spPr>
-          <a:xfrm>
-            <a:off x="640080" y="5029200"/>
-            <a:ext cx="3294888" cy="384048"/>
+          <p:cNvPr id="21" name="Text 18"/>
+          <p:cNvSpPr/>
+          <p:nvPr/>
+        </p:nvSpPr>
+        <p:spPr>
+          <a:xfrm>
+            <a:off x="640080" y="5212080"/>
+            <a:ext cx="3294888" cy="292608"/>
           </a:xfrm>
           <a:prstGeom prst="rect">
             <a:avLst/>
@@ -6070,7 +6031,7 @@
               <a:buNone/>
             </a:pPr>
             <a:r>
-              <a:rPr lang="en-US" sz="1800" b="1" dirty="0">
+              <a:rPr lang="en-US" sz="1600" b="1" dirty="0">
                 <a:solidFill>
                   <a:srgbClr val="FFFFFF"/>
                 </a:solidFill>
@@ -6080,20 +6041,20 @@
               </a:rPr>
               <a:t>&lt;5ms</a:t>
             </a:r>
-            <a:endParaRPr lang="en-US" sz="1800" dirty="0"/>
-          </a:p>
-        </p:txBody>
-      </p:sp>
-      <p:sp>
-        <p:nvSpPr>
-          <p:cNvPr id="23" name="Text 20"/>
-          <p:cNvSpPr/>
-          <p:nvPr/>
-        </p:nvSpPr>
-        <p:spPr>
-          <a:xfrm>
-            <a:off x="640080" y="5394960"/>
-            <a:ext cx="3294888" cy="292608"/>
+            <a:endParaRPr lang="en-US" sz="1600" dirty="0"/>
+          </a:p>
+        </p:txBody>
+      </p:sp>
+      <p:sp>
+        <p:nvSpPr>
+          <p:cNvPr id="22" name="Text 19"/>
+          <p:cNvSpPr/>
+          <p:nvPr/>
+        </p:nvSpPr>
+        <p:spPr>
+          <a:xfrm>
+            <a:off x="640080" y="5486400"/>
+            <a:ext cx="3294888" cy="237744"/>
           </a:xfrm>
           <a:prstGeom prst="rect">
             <a:avLst/>
@@ -6109,7 +6070,7 @@
               <a:buNone/>
             </a:pPr>
             <a:r>
-              <a:rPr lang="en-US" sz="1000" dirty="0">
+              <a:rPr lang="en-US" sz="900" dirty="0">
                 <a:solidFill>
                   <a:srgbClr val="FFFFFF"/>
                 </a:solidFill>
@@ -6119,13 +6080,13 @@
               </a:rPr>
               <a:t>台灣平均延遲</a:t>
             </a:r>
-            <a:endParaRPr lang="en-US" sz="1000" dirty="0"/>
-          </a:p>
-        </p:txBody>
-      </p:sp>
-      <p:sp>
-        <p:nvSpPr>
-          <p:cNvPr id="24" name="Shape 21"/>
+            <a:endParaRPr lang="en-US" sz="900" dirty="0"/>
+          </a:p>
+        </p:txBody>
+      </p:sp>
+      <p:sp>
+        <p:nvSpPr>
+          <p:cNvPr id="23" name="Shape 20"/>
           <p:cNvSpPr/>
           <p:nvPr/>
         </p:nvSpPr>
@@ -6150,7 +6111,7 @@
       </p:sp>
       <p:sp>
         <p:nvSpPr>
-          <p:cNvPr id="25" name="Shape 22"/>
+          <p:cNvPr id="24" name="Shape 21"/>
           <p:cNvSpPr/>
           <p:nvPr/>
         </p:nvSpPr>
@@ -6170,7 +6131,7 @@
       </p:sp>
       <p:sp>
         <p:nvSpPr>
-          <p:cNvPr id="26" name="Text 23"/>
+          <p:cNvPr id="25" name="Text 22"/>
           <p:cNvSpPr/>
           <p:nvPr/>
         </p:nvSpPr>
@@ -6209,7 +6170,7 @@
       </p:sp>
       <p:sp>
         <p:nvSpPr>
-          <p:cNvPr id="27" name="Text 24"/>
+          <p:cNvPr id="26" name="Text 23"/>
           <p:cNvSpPr/>
           <p:nvPr/>
         </p:nvSpPr>
@@ -6248,7 +6209,7 @@
       </p:sp>
       <p:sp>
         <p:nvSpPr>
-          <p:cNvPr id="28" name="Text 25"/>
+          <p:cNvPr id="27" name="Text 24"/>
           <p:cNvSpPr/>
           <p:nvPr/>
         </p:nvSpPr>
@@ -6287,7 +6248,7 @@
       </p:sp>
       <p:sp>
         <p:nvSpPr>
-          <p:cNvPr id="29" name="Text 26"/>
+          <p:cNvPr id="28" name="Text 25"/>
           <p:cNvSpPr/>
           <p:nvPr/>
         </p:nvSpPr>
@@ -6326,7 +6287,7 @@
       </p:sp>
       <p:sp>
         <p:nvSpPr>
-          <p:cNvPr id="30" name="Shape 27"/>
+          <p:cNvPr id="29" name="Shape 26"/>
           <p:cNvSpPr/>
           <p:nvPr/>
         </p:nvSpPr>
@@ -6346,14 +6307,53 @@
       </p:sp>
       <p:sp>
         <p:nvSpPr>
+          <p:cNvPr id="30" name="Text 27"/>
+          <p:cNvSpPr/>
+          <p:nvPr/>
+        </p:nvSpPr>
+        <p:spPr>
+          <a:xfrm>
+            <a:off x="4447032" y="3474720"/>
+            <a:ext cx="3294888" cy="365760"/>
+          </a:xfrm>
+          <a:prstGeom prst="rect">
+            <a:avLst/>
+          </a:prstGeom>
+          <a:noFill/>
+          <a:ln/>
+        </p:spPr>
+        <p:txBody>
+          <a:bodyPr wrap="square" rtlCol="0" anchor="ctr"/>
+          <a:lstStyle/>
+          <a:p>
+            <a:pPr indent="0" marL="0">
+              <a:buNone/>
+            </a:pPr>
+            <a:r>
+              <a:rPr lang="en-US" sz="1100" dirty="0">
+                <a:solidFill>
+                  <a:srgbClr val="444444"/>
+                </a:solidFill>
+                <a:latin typeface="微軟正黑體" pitchFamily="34" charset="0"/>
+                <a:ea typeface="微軟正黑體" pitchFamily="34" charset="-122"/>
+                <a:cs typeface="微軟正黑體" pitchFamily="34" charset="-120"/>
+              </a:rPr>
+              <a:t>▸  51+ LLM 模型統一入口</a:t>
+            </a:r>
+            <a:endParaRPr lang="en-US" sz="1100" dirty="0"/>
+          </a:p>
+        </p:txBody>
+      </p:sp>
+      <p:sp>
+        <p:nvSpPr>
           <p:cNvPr id="31" name="Text 28"/>
           <p:cNvSpPr/>
           <p:nvPr/>
         </p:nvSpPr>
         <p:spPr>
           <a:xfrm>
-            <a:off x="4447032" y="3474720"/>
-            <a:ext cx="3294888" cy="457200"/>
+            <a:off x="4447032" y="3886200"/>
+            <a:ext cx="3294888" cy="365760"/>
           </a:xfrm>
           <a:prstGeom prst="rect">
             <a:avLst/>
@@ -6377,7 +6377,7 @@
                 <a:ea typeface="微軟正黑體" pitchFamily="34" charset="-122"/>
                 <a:cs typeface="微軟正黑體" pitchFamily="34" charset="-120"/>
               </a:rPr>
-              <a:t>▸  51+ LLM 模型統一入口</a:t>
+              <a:t>▸  API Key 由 Gateway 後端保管</a:t>
             </a:r>
             <a:endParaRPr lang="en-US" sz="1100" dirty="0"/>
           </a:p>
@@ -6391,8 +6391,8 @@
         </p:nvSpPr>
         <p:spPr>
           <a:xfrm>
-            <a:off x="4447032" y="3977640"/>
-            <a:ext cx="3294888" cy="457200"/>
+            <a:off x="4447032" y="4297680"/>
+            <a:ext cx="3294888" cy="365760"/>
           </a:xfrm>
           <a:prstGeom prst="rect">
             <a:avLst/>
@@ -6416,7 +6416,7 @@
                 <a:ea typeface="微軟正黑體" pitchFamily="34" charset="-122"/>
                 <a:cs typeface="微軟正黑體" pitchFamily="34" charset="-120"/>
               </a:rPr>
-              <a:t>▸  API Key 由 Gateway 後端保管</a:t>
+              <a:t>▸  Policy Engine 部門/職級控管</a:t>
             </a:r>
             <a:endParaRPr lang="en-US" sz="1100" dirty="0"/>
           </a:p>
@@ -6430,8 +6430,8 @@
         </p:nvSpPr>
         <p:spPr>
           <a:xfrm>
-            <a:off x="4447032" y="4480560"/>
-            <a:ext cx="3294888" cy="457200"/>
+            <a:off x="4447032" y="4709160"/>
+            <a:ext cx="3294888" cy="365760"/>
           </a:xfrm>
           <a:prstGeom prst="rect">
             <a:avLst/>
@@ -6455,7 +6455,7 @@
                 <a:ea typeface="微軟正黑體" pitchFamily="34" charset="-122"/>
                 <a:cs typeface="微軟正黑體" pitchFamily="34" charset="-120"/>
               </a:rPr>
-              <a:t>▸  Policy Engine 部門/職級控管</a:t>
+              <a:t>▸  Guardrails 自動偵測 PII</a:t>
             </a:r>
             <a:endParaRPr lang="en-US" sz="1100" dirty="0"/>
           </a:p>
@@ -6463,92 +6463,14 @@
       </p:sp>
       <p:sp>
         <p:nvSpPr>
-          <p:cNvPr id="34" name="Text 31"/>
-          <p:cNvSpPr/>
-          <p:nvPr/>
-        </p:nvSpPr>
-        <p:spPr>
-          <a:xfrm>
-            <a:off x="4447032" y="4983480"/>
-            <a:ext cx="3294888" cy="457200"/>
-          </a:xfrm>
-          <a:prstGeom prst="rect">
-            <a:avLst/>
-          </a:prstGeom>
-          <a:noFill/>
-          <a:ln/>
-        </p:spPr>
-        <p:txBody>
-          <a:bodyPr wrap="square" rtlCol="0" anchor="ctr"/>
-          <a:lstStyle/>
-          <a:p>
-            <a:pPr indent="0" marL="0">
-              <a:buNone/>
-            </a:pPr>
-            <a:r>
-              <a:rPr lang="en-US" sz="1100" dirty="0">
-                <a:solidFill>
-                  <a:srgbClr val="444444"/>
-                </a:solidFill>
-                <a:latin typeface="微軟正黑體" pitchFamily="34" charset="0"/>
-                <a:ea typeface="微軟正黑體" pitchFamily="34" charset="-122"/>
-                <a:cs typeface="微軟正黑體" pitchFamily="34" charset="-120"/>
-              </a:rPr>
-              <a:t>▸  Guardrails 自動偵測 PII</a:t>
-            </a:r>
-            <a:endParaRPr lang="en-US" sz="1100" dirty="0"/>
-          </a:p>
-        </p:txBody>
-      </p:sp>
-      <p:sp>
-        <p:nvSpPr>
-          <p:cNvPr id="35" name="Text 32"/>
-          <p:cNvSpPr/>
-          <p:nvPr/>
-        </p:nvSpPr>
-        <p:spPr>
-          <a:xfrm>
-            <a:off x="4447032" y="5486400"/>
-            <a:ext cx="3294888" cy="457200"/>
-          </a:xfrm>
-          <a:prstGeom prst="rect">
-            <a:avLst/>
-          </a:prstGeom>
-          <a:noFill/>
-          <a:ln/>
-        </p:spPr>
-        <p:txBody>
-          <a:bodyPr wrap="square" rtlCol="0" anchor="ctr"/>
-          <a:lstStyle/>
-          <a:p>
-            <a:pPr indent="0" marL="0">
-              <a:buNone/>
-            </a:pPr>
-            <a:r>
-              <a:rPr lang="en-US" sz="1100" dirty="0">
-                <a:solidFill>
-                  <a:srgbClr val="444444"/>
-                </a:solidFill>
-                <a:latin typeface="微軟正黑體" pitchFamily="34" charset="0"/>
-                <a:ea typeface="微軟正黑體" pitchFamily="34" charset="-122"/>
-                <a:cs typeface="微軟正黑體" pitchFamily="34" charset="-120"/>
-              </a:rPr>
-              <a:t>▸  完整 Logs / Analytics 儀表板</a:t>
-            </a:r>
-            <a:endParaRPr lang="en-US" sz="1100" dirty="0"/>
-          </a:p>
-        </p:txBody>
-      </p:sp>
-      <p:sp>
-        <p:nvSpPr>
-          <p:cNvPr id="36" name="Shape 33"/>
-          <p:cNvSpPr/>
-          <p:nvPr/>
-        </p:nvSpPr>
-        <p:spPr>
-          <a:xfrm>
-            <a:off x="4447032" y="5029200"/>
-            <a:ext cx="3294888" cy="658368"/>
+          <p:cNvPr id="34" name="Shape 31"/>
+          <p:cNvSpPr/>
+          <p:nvPr/>
+        </p:nvSpPr>
+        <p:spPr>
+          <a:xfrm>
+            <a:off x="4447032" y="5212080"/>
+            <a:ext cx="3294888" cy="502920"/>
           </a:xfrm>
           <a:prstGeom prst="rect">
             <a:avLst/>
@@ -6561,14 +6483,14 @@
       </p:sp>
       <p:sp>
         <p:nvSpPr>
-          <p:cNvPr id="37" name="Text 34"/>
-          <p:cNvSpPr/>
-          <p:nvPr/>
-        </p:nvSpPr>
-        <p:spPr>
-          <a:xfrm>
-            <a:off x="4447032" y="5029200"/>
-            <a:ext cx="3294888" cy="384048"/>
+          <p:cNvPr id="35" name="Text 32"/>
+          <p:cNvSpPr/>
+          <p:nvPr/>
+        </p:nvSpPr>
+        <p:spPr>
+          <a:xfrm>
+            <a:off x="4447032" y="5212080"/>
+            <a:ext cx="3294888" cy="292608"/>
           </a:xfrm>
           <a:prstGeom prst="rect">
             <a:avLst/>
@@ -6584,7 +6506,7 @@
               <a:buNone/>
             </a:pPr>
             <a:r>
-              <a:rPr lang="en-US" sz="1800" b="1" dirty="0">
+              <a:rPr lang="en-US" sz="1600" b="1" dirty="0">
                 <a:solidFill>
                   <a:srgbClr val="FFFFFF"/>
                 </a:solidFill>
@@ -6594,20 +6516,20 @@
               </a:rPr>
               <a:t>51+</a:t>
             </a:r>
-            <a:endParaRPr lang="en-US" sz="1800" dirty="0"/>
-          </a:p>
-        </p:txBody>
-      </p:sp>
-      <p:sp>
-        <p:nvSpPr>
-          <p:cNvPr id="38" name="Text 35"/>
-          <p:cNvSpPr/>
-          <p:nvPr/>
-        </p:nvSpPr>
-        <p:spPr>
-          <a:xfrm>
-            <a:off x="4447032" y="5394960"/>
-            <a:ext cx="3294888" cy="292608"/>
+            <a:endParaRPr lang="en-US" sz="1600" dirty="0"/>
+          </a:p>
+        </p:txBody>
+      </p:sp>
+      <p:sp>
+        <p:nvSpPr>
+          <p:cNvPr id="36" name="Text 33"/>
+          <p:cNvSpPr/>
+          <p:nvPr/>
+        </p:nvSpPr>
+        <p:spPr>
+          <a:xfrm>
+            <a:off x="4447032" y="5486400"/>
+            <a:ext cx="3294888" cy="237744"/>
           </a:xfrm>
           <a:prstGeom prst="rect">
             <a:avLst/>
@@ -6623,7 +6545,7 @@
               <a:buNone/>
             </a:pPr>
             <a:r>
-              <a:rPr lang="en-US" sz="1000" dirty="0">
+              <a:rPr lang="en-US" sz="900" dirty="0">
                 <a:solidFill>
                   <a:srgbClr val="FFFFFF"/>
                 </a:solidFill>
@@ -6633,20 +6555,20 @@
               </a:rPr>
               <a:t>可管理模型數</a:t>
             </a:r>
-            <a:endParaRPr lang="en-US" sz="1000" dirty="0"/>
-          </a:p>
-        </p:txBody>
-      </p:sp>
-      <p:sp>
-        <p:nvSpPr>
-          <p:cNvPr id="39" name="Shape 36"/>
-          <p:cNvSpPr/>
-          <p:nvPr/>
-        </p:nvSpPr>
-        <p:spPr>
-          <a:xfrm>
-            <a:off x="5180076" y="1371600"/>
-            <a:ext cx="1828800" cy="320040"/>
+            <a:endParaRPr lang="en-US" sz="900" dirty="0"/>
+          </a:p>
+        </p:txBody>
+      </p:sp>
+      <p:sp>
+        <p:nvSpPr>
+          <p:cNvPr id="37" name="Shape 34"/>
+          <p:cNvSpPr/>
+          <p:nvPr/>
+        </p:nvSpPr>
+        <p:spPr>
+          <a:xfrm>
+            <a:off x="5180076" y="1508760"/>
+            <a:ext cx="1828800" cy="274320"/>
           </a:xfrm>
           <a:prstGeom prst="rect">
             <a:avLst/>
@@ -6659,14 +6581,14 @@
       </p:sp>
       <p:sp>
         <p:nvSpPr>
-          <p:cNvPr id="40" name="Text 37"/>
-          <p:cNvSpPr/>
-          <p:nvPr/>
-        </p:nvSpPr>
-        <p:spPr>
-          <a:xfrm>
-            <a:off x="5180076" y="1371600"/>
-            <a:ext cx="1828800" cy="320040"/>
+          <p:cNvPr id="38" name="Text 35"/>
+          <p:cNvSpPr/>
+          <p:nvPr/>
+        </p:nvSpPr>
+        <p:spPr>
+          <a:xfrm>
+            <a:off x="5180076" y="1508760"/>
+            <a:ext cx="1828800" cy="274320"/>
           </a:xfrm>
           <a:prstGeom prst="rect">
             <a:avLst/>
@@ -6698,7 +6620,7 @@
       </p:sp>
       <p:sp>
         <p:nvSpPr>
-          <p:cNvPr id="41" name="Shape 38"/>
+          <p:cNvPr id="39" name="Shape 36"/>
           <p:cNvSpPr/>
           <p:nvPr/>
         </p:nvSpPr>
@@ -6723,7 +6645,7 @@
       </p:sp>
       <p:sp>
         <p:nvSpPr>
-          <p:cNvPr id="42" name="Shape 39"/>
+          <p:cNvPr id="40" name="Shape 37"/>
           <p:cNvSpPr/>
           <p:nvPr/>
         </p:nvSpPr>
@@ -6743,7 +6665,7 @@
       </p:sp>
       <p:sp>
         <p:nvSpPr>
-          <p:cNvPr id="43" name="Text 40"/>
+          <p:cNvPr id="41" name="Text 38"/>
           <p:cNvSpPr/>
           <p:nvPr/>
         </p:nvSpPr>
@@ -6782,7 +6704,7 @@
       </p:sp>
       <p:sp>
         <p:nvSpPr>
-          <p:cNvPr id="44" name="Text 41"/>
+          <p:cNvPr id="42" name="Text 39"/>
           <p:cNvSpPr/>
           <p:nvPr/>
         </p:nvSpPr>
@@ -6821,7 +6743,7 @@
       </p:sp>
       <p:sp>
         <p:nvSpPr>
-          <p:cNvPr id="45" name="Text 42"/>
+          <p:cNvPr id="43" name="Text 40"/>
           <p:cNvSpPr/>
           <p:nvPr/>
         </p:nvSpPr>
@@ -6860,7 +6782,7 @@
       </p:sp>
       <p:sp>
         <p:nvSpPr>
-          <p:cNvPr id="46" name="Text 43"/>
+          <p:cNvPr id="44" name="Text 41"/>
           <p:cNvSpPr/>
           <p:nvPr/>
         </p:nvSpPr>
@@ -6899,7 +6821,7 @@
       </p:sp>
       <p:sp>
         <p:nvSpPr>
-          <p:cNvPr id="47" name="Shape 44"/>
+          <p:cNvPr id="45" name="Shape 42"/>
           <p:cNvSpPr/>
           <p:nvPr/>
         </p:nvSpPr>
@@ -6919,14 +6841,92 @@
       </p:sp>
       <p:sp>
         <p:nvSpPr>
+          <p:cNvPr id="46" name="Text 43"/>
+          <p:cNvSpPr/>
+          <p:nvPr/>
+        </p:nvSpPr>
+        <p:spPr>
+          <a:xfrm>
+            <a:off x="8253984" y="3474720"/>
+            <a:ext cx="3294888" cy="365760"/>
+          </a:xfrm>
+          <a:prstGeom prst="rect">
+            <a:avLst/>
+          </a:prstGeom>
+          <a:noFill/>
+          <a:ln/>
+        </p:spPr>
+        <p:txBody>
+          <a:bodyPr wrap="square" rtlCol="0" anchor="ctr"/>
+          <a:lstStyle/>
+          <a:p>
+            <a:pPr indent="0" marL="0">
+              <a:buNone/>
+            </a:pPr>
+            <a:r>
+              <a:rPr lang="en-US" sz="1100" dirty="0">
+                <a:solidFill>
+                  <a:srgbClr val="444444"/>
+                </a:solidFill>
+                <a:latin typeface="微軟正黑體" pitchFamily="34" charset="0"/>
+                <a:ea typeface="微軟正黑體" pitchFamily="34" charset="-122"/>
+                <a:cs typeface="微軟正黑體" pitchFamily="34" charset="-120"/>
+              </a:rPr>
+              <a:t>▸  MCP 標準工具呼叫協議</a:t>
+            </a:r>
+            <a:endParaRPr lang="en-US" sz="1100" dirty="0"/>
+          </a:p>
+        </p:txBody>
+      </p:sp>
+      <p:sp>
+        <p:nvSpPr>
+          <p:cNvPr id="47" name="Text 44"/>
+          <p:cNvSpPr/>
+          <p:nvPr/>
+        </p:nvSpPr>
+        <p:spPr>
+          <a:xfrm>
+            <a:off x="8253984" y="3886200"/>
+            <a:ext cx="3294888" cy="365760"/>
+          </a:xfrm>
+          <a:prstGeom prst="rect">
+            <a:avLst/>
+          </a:prstGeom>
+          <a:noFill/>
+          <a:ln/>
+        </p:spPr>
+        <p:txBody>
+          <a:bodyPr wrap="square" rtlCol="0" anchor="ctr"/>
+          <a:lstStyle/>
+          <a:p>
+            <a:pPr indent="0" marL="0">
+              <a:buNone/>
+            </a:pPr>
+            <a:r>
+              <a:rPr lang="en-US" sz="1100" dirty="0">
+                <a:solidFill>
+                  <a:srgbClr val="444444"/>
+                </a:solidFill>
+                <a:latin typeface="微軟正黑體" pitchFamily="34" charset="0"/>
+                <a:ea typeface="微軟正黑體" pitchFamily="34" charset="-122"/>
+                <a:cs typeface="微軟正黑體" pitchFamily="34" charset="-120"/>
+              </a:rPr>
+              <a:t>▸  相容 OpenAI / Anthropic / Google</a:t>
+            </a:r>
+            <a:endParaRPr lang="en-US" sz="1100" dirty="0"/>
+          </a:p>
+        </p:txBody>
+      </p:sp>
+      <p:sp>
+        <p:nvSpPr>
           <p:cNvPr id="48" name="Text 45"/>
           <p:cNvSpPr/>
           <p:nvPr/>
         </p:nvSpPr>
         <p:spPr>
           <a:xfrm>
-            <a:off x="8253984" y="3474720"/>
-            <a:ext cx="3294888" cy="457200"/>
+            <a:off x="8253984" y="4297680"/>
+            <a:ext cx="3294888" cy="365760"/>
           </a:xfrm>
           <a:prstGeom prst="rect">
             <a:avLst/>
@@ -6950,7 +6950,7 @@
                 <a:ea typeface="微軟正黑體" pitchFamily="34" charset="-122"/>
                 <a:cs typeface="微軟正黑體" pitchFamily="34" charset="-120"/>
               </a:rPr>
-              <a:t>▸  MCP 標準工具呼叫協議</a:t>
+              <a:t>▸  Workers AI 邊緣推論一併使用</a:t>
             </a:r>
             <a:endParaRPr lang="en-US" sz="1100" dirty="0"/>
           </a:p>
@@ -6964,8 +6964,8 @@
         </p:nvSpPr>
         <p:spPr>
           <a:xfrm>
-            <a:off x="8253984" y="3977640"/>
-            <a:ext cx="3294888" cy="457200"/>
+            <a:off x="8253984" y="4709160"/>
+            <a:ext cx="3294888" cy="365760"/>
           </a:xfrm>
           <a:prstGeom prst="rect">
             <a:avLst/>
@@ -6989,7 +6989,7 @@
                 <a:ea typeface="微軟正黑體" pitchFamily="34" charset="-122"/>
                 <a:cs typeface="微軟正黑體" pitchFamily="34" charset="-120"/>
               </a:rPr>
-              <a:t>▸  相容 OpenAI / Anthropic / Google</a:t>
+              <a:t>▸  完整官方文件 + 教學範例</a:t>
             </a:r>
             <a:endParaRPr lang="en-US" sz="1100" dirty="0"/>
           </a:p>
@@ -6997,131 +6997,14 @@
       </p:sp>
       <p:sp>
         <p:nvSpPr>
-          <p:cNvPr id="50" name="Text 47"/>
-          <p:cNvSpPr/>
-          <p:nvPr/>
-        </p:nvSpPr>
-        <p:spPr>
-          <a:xfrm>
-            <a:off x="8253984" y="4480560"/>
-            <a:ext cx="3294888" cy="457200"/>
-          </a:xfrm>
-          <a:prstGeom prst="rect">
-            <a:avLst/>
-          </a:prstGeom>
-          <a:noFill/>
-          <a:ln/>
-        </p:spPr>
-        <p:txBody>
-          <a:bodyPr wrap="square" rtlCol="0" anchor="ctr"/>
-          <a:lstStyle/>
-          <a:p>
-            <a:pPr indent="0" marL="0">
-              <a:buNone/>
-            </a:pPr>
-            <a:r>
-              <a:rPr lang="en-US" sz="1100" dirty="0">
-                <a:solidFill>
-                  <a:srgbClr val="444444"/>
-                </a:solidFill>
-                <a:latin typeface="微軟正黑體" pitchFamily="34" charset="0"/>
-                <a:ea typeface="微軟正黑體" pitchFamily="34" charset="-122"/>
-                <a:cs typeface="微軟正黑體" pitchFamily="34" charset="-120"/>
-              </a:rPr>
-              <a:t>▸  Workers AI 邊緣推論一併使用</a:t>
-            </a:r>
-            <a:endParaRPr lang="en-US" sz="1100" dirty="0"/>
-          </a:p>
-        </p:txBody>
-      </p:sp>
-      <p:sp>
-        <p:nvSpPr>
-          <p:cNvPr id="51" name="Text 48"/>
-          <p:cNvSpPr/>
-          <p:nvPr/>
-        </p:nvSpPr>
-        <p:spPr>
-          <a:xfrm>
-            <a:off x="8253984" y="4983480"/>
-            <a:ext cx="3294888" cy="457200"/>
-          </a:xfrm>
-          <a:prstGeom prst="rect">
-            <a:avLst/>
-          </a:prstGeom>
-          <a:noFill/>
-          <a:ln/>
-        </p:spPr>
-        <p:txBody>
-          <a:bodyPr wrap="square" rtlCol="0" anchor="ctr"/>
-          <a:lstStyle/>
-          <a:p>
-            <a:pPr indent="0" marL="0">
-              <a:buNone/>
-            </a:pPr>
-            <a:r>
-              <a:rPr lang="en-US" sz="1100" dirty="0">
-                <a:solidFill>
-                  <a:srgbClr val="444444"/>
-                </a:solidFill>
-                <a:latin typeface="微軟正黑體" pitchFamily="34" charset="0"/>
-                <a:ea typeface="微軟正黑體" pitchFamily="34" charset="-122"/>
-                <a:cs typeface="微軟正黑體" pitchFamily="34" charset="-120"/>
-              </a:rPr>
-              <a:t>▸  工具開發者社群活躍</a:t>
-            </a:r>
-            <a:endParaRPr lang="en-US" sz="1100" dirty="0"/>
-          </a:p>
-        </p:txBody>
-      </p:sp>
-      <p:sp>
-        <p:nvSpPr>
-          <p:cNvPr id="52" name="Text 49"/>
-          <p:cNvSpPr/>
-          <p:nvPr/>
-        </p:nvSpPr>
-        <p:spPr>
-          <a:xfrm>
-            <a:off x="8253984" y="5486400"/>
-            <a:ext cx="3294888" cy="457200"/>
-          </a:xfrm>
-          <a:prstGeom prst="rect">
-            <a:avLst/>
-          </a:prstGeom>
-          <a:noFill/>
-          <a:ln/>
-        </p:spPr>
-        <p:txBody>
-          <a:bodyPr wrap="square" rtlCol="0" anchor="ctr"/>
-          <a:lstStyle/>
-          <a:p>
-            <a:pPr indent="0" marL="0">
-              <a:buNone/>
-            </a:pPr>
-            <a:r>
-              <a:rPr lang="en-US" sz="1100" dirty="0">
-                <a:solidFill>
-                  <a:srgbClr val="444444"/>
-                </a:solidFill>
-                <a:latin typeface="微軟正黑體" pitchFamily="34" charset="0"/>
-                <a:ea typeface="微軟正黑體" pitchFamily="34" charset="-122"/>
-                <a:cs typeface="微軟正黑體" pitchFamily="34" charset="-120"/>
-              </a:rPr>
-              <a:t>▸  完整官方文件 + 教學範例</a:t>
-            </a:r>
-            <a:endParaRPr lang="en-US" sz="1100" dirty="0"/>
-          </a:p>
-        </p:txBody>
-      </p:sp>
-      <p:sp>
-        <p:nvSpPr>
-          <p:cNvPr id="53" name="Shape 50"/>
-          <p:cNvSpPr/>
-          <p:nvPr/>
-        </p:nvSpPr>
-        <p:spPr>
-          <a:xfrm>
-            <a:off x="8253984" y="5029200"/>
-            <a:ext cx="3294888" cy="658368"/>
+          <p:cNvPr id="50" name="Shape 47"/>
+          <p:cNvSpPr/>
+          <p:nvPr/>
+        </p:nvSpPr>
+        <p:spPr>
+          <a:xfrm>
+            <a:off x="8253984" y="5212080"/>
+            <a:ext cx="3294888" cy="502920"/>
           </a:xfrm>
           <a:prstGeom prst="rect">
             <a:avLst/>
@@ -7134,14 +7017,14 @@
       </p:sp>
       <p:sp>
         <p:nvSpPr>
-          <p:cNvPr id="54" name="Text 51"/>
-          <p:cNvSpPr/>
-          <p:nvPr/>
-        </p:nvSpPr>
-        <p:spPr>
-          <a:xfrm>
-            <a:off x="8253984" y="5029200"/>
-            <a:ext cx="3294888" cy="384048"/>
+          <p:cNvPr id="51" name="Text 48"/>
+          <p:cNvSpPr/>
+          <p:nvPr/>
+        </p:nvSpPr>
+        <p:spPr>
+          <a:xfrm>
+            <a:off x="8253984" y="5212080"/>
+            <a:ext cx="3294888" cy="292608"/>
           </a:xfrm>
           <a:prstGeom prst="rect">
             <a:avLst/>
@@ -7157,7 +7040,7 @@
               <a:buNone/>
             </a:pPr>
             <a:r>
-              <a:rPr lang="en-US" sz="1800" b="1" dirty="0">
+              <a:rPr lang="en-US" sz="1600" b="1" dirty="0">
                 <a:solidFill>
                   <a:srgbClr val="FFFFFF"/>
                 </a:solidFill>
@@ -7167,20 +7050,20 @@
               </a:rPr>
               <a:t>MCP</a:t>
             </a:r>
-            <a:endParaRPr lang="en-US" sz="1800" dirty="0"/>
-          </a:p>
-        </p:txBody>
-      </p:sp>
-      <p:sp>
-        <p:nvSpPr>
-          <p:cNvPr id="55" name="Text 52"/>
-          <p:cNvSpPr/>
-          <p:nvPr/>
-        </p:nvSpPr>
-        <p:spPr>
-          <a:xfrm>
-            <a:off x="8253984" y="5394960"/>
-            <a:ext cx="3294888" cy="292608"/>
+            <a:endParaRPr lang="en-US" sz="1600" dirty="0"/>
+          </a:p>
+        </p:txBody>
+      </p:sp>
+      <p:sp>
+        <p:nvSpPr>
+          <p:cNvPr id="52" name="Text 49"/>
+          <p:cNvSpPr/>
+          <p:nvPr/>
+        </p:nvSpPr>
+        <p:spPr>
+          <a:xfrm>
+            <a:off x="8253984" y="5486400"/>
+            <a:ext cx="3294888" cy="237744"/>
           </a:xfrm>
           <a:prstGeom prst="rect">
             <a:avLst/>
@@ -7196,7 +7079,7 @@
               <a:buNone/>
             </a:pPr>
             <a:r>
-              <a:rPr lang="en-US" sz="1000" dirty="0">
+              <a:rPr lang="en-US" sz="900" dirty="0">
                 <a:solidFill>
                   <a:srgbClr val="FFFFFF"/>
                 </a:solidFill>
@@ -7206,13 +7089,13 @@
               </a:rPr>
               <a:t>開放協議</a:t>
             </a:r>
-            <a:endParaRPr lang="en-US" sz="1000" dirty="0"/>
-          </a:p>
-        </p:txBody>
-      </p:sp>
-      <p:sp>
-        <p:nvSpPr>
-          <p:cNvPr id="56" name="Shape 53"/>
+            <a:endParaRPr lang="en-US" sz="900" dirty="0"/>
+          </a:p>
+        </p:txBody>
+      </p:sp>
+      <p:sp>
+        <p:nvSpPr>
+          <p:cNvPr id="53" name="Shape 50"/>
           <p:cNvSpPr/>
           <p:nvPr/>
         </p:nvSpPr>
@@ -7234,7 +7117,7 @@
       </p:sp>
       <p:sp>
         <p:nvSpPr>
-          <p:cNvPr id="57" name="Shape 54"/>
+          <p:cNvPr id="54" name="Shape 51"/>
           <p:cNvSpPr/>
           <p:nvPr/>
         </p:nvSpPr>
@@ -7254,7 +7137,7 @@
       </p:sp>
       <p:sp>
         <p:nvSpPr>
-          <p:cNvPr id="58" name="Text 55"/>
+          <p:cNvPr id="55" name="Text 52"/>
           <p:cNvSpPr/>
           <p:nvPr/>
         </p:nvSpPr>

</xml_diff>